<commit_message>
README updated to remove warning
</commit_message>
<xml_diff>
--- a/P1Presentation_MiguelPena.pptx
+++ b/P1Presentation_MiguelPena.pptx
@@ -5,17 +5,18 @@
     <p:sldMasterId id="2147483799" r:id="rId4"/>
   </p:sldMasterIdLst>
   <p:notesMasterIdLst>
-    <p:notesMasterId r:id="rId10"/>
+    <p:notesMasterId r:id="rId11"/>
   </p:notesMasterIdLst>
   <p:handoutMasterIdLst>
-    <p:handoutMasterId r:id="rId11"/>
+    <p:handoutMasterId r:id="rId12"/>
   </p:handoutMasterIdLst>
   <p:sldIdLst>
     <p:sldId id="256" r:id="rId5"/>
     <p:sldId id="292" r:id="rId6"/>
     <p:sldId id="266" r:id="rId7"/>
     <p:sldId id="293" r:id="rId8"/>
-    <p:sldId id="294" r:id="rId9"/>
+    <p:sldId id="295" r:id="rId9"/>
+    <p:sldId id="294" r:id="rId10"/>
   </p:sldIdLst>
   <p:sldSz cx="12192000" cy="6858000"/>
   <p:notesSz cx="6858000" cy="9144000"/>
@@ -3232,7 +3233,7 @@
           <a:p>
             <a:fld id="{7B97C6B7-F63D-48F8-8C65-A57506B0F13B}" type="datetimeFigureOut">
               <a:rPr lang="en-US" smtClean="0"/>
-              <a:t>7/30/2024</a:t>
+              <a:t>1/13/2025</a:t>
             </a:fld>
             <a:endParaRPr lang="en-US" dirty="0"/>
           </a:p>
@@ -3409,7 +3410,7 @@
           <a:p>
             <a:fld id="{AC09A0FA-2191-4F92-A1E4-6EB4598AC4EC}" type="datetimeFigureOut">
               <a:rPr lang="en-US" smtClean="0"/>
-              <a:t>7/30/2024</a:t>
+              <a:t>1/13/2025</a:t>
             </a:fld>
             <a:endParaRPr lang="en-US" dirty="0"/>
           </a:p>
@@ -8946,7 +8947,7 @@
                   <a:srgbClr val="FFFFFF"/>
                 </a:solidFill>
               </a:rPr>
-              <a:t>Project 1</a:t>
+              <a:t>Project 1:</a:t>
             </a:r>
             <a:br>
               <a:rPr lang="en-US" sz="4000" dirty="0">
@@ -9088,7 +9089,7 @@
         <p:spPr>
           <a:xfrm>
             <a:off x="638620" y="4211782"/>
-            <a:ext cx="3037087" cy="1631216"/>
+            <a:ext cx="3037087" cy="1938992"/>
           </a:xfrm>
           <a:prstGeom prst="rect">
             <a:avLst/>
@@ -9112,7 +9113,7 @@
           <a:p>
             <a:r>
               <a:rPr lang="en-US" sz="2000" dirty="0"/>
-              <a:t>{https://github.com/miguelpena-bigdata-dev/project-one}</a:t>
+              <a:t>{https://github.com/BigData2025-Rev/miguelpena-projectone-finished-version}</a:t>
             </a:r>
           </a:p>
         </p:txBody>
@@ -10037,6 +10038,98 @@
 </file>
 
 <file path=ppt/slides/slide5.xml><?xml version="1.0" encoding="utf-8"?>
+<p:sld xmlns:a="http://schemas.openxmlformats.org/drawingml/2006/main" xmlns:r="http://schemas.openxmlformats.org/officeDocument/2006/relationships" xmlns:p="http://schemas.openxmlformats.org/presentationml/2006/main">
+  <p:cSld>
+    <p:spTree>
+      <p:nvGrpSpPr>
+        <p:cNvPr id="1" name=""/>
+        <p:cNvGrpSpPr/>
+        <p:nvPr/>
+      </p:nvGrpSpPr>
+      <p:grpSpPr>
+        <a:xfrm>
+          <a:off x="0" y="0"/>
+          <a:ext cx="0" cy="0"/>
+          <a:chOff x="0" y="0"/>
+          <a:chExt cx="0" cy="0"/>
+        </a:xfrm>
+      </p:grpSpPr>
+      <p:sp>
+        <p:nvSpPr>
+          <p:cNvPr id="2" name="Title 1">
+            <a:extLst>
+              <a:ext uri="{FF2B5EF4-FFF2-40B4-BE49-F238E27FC236}">
+                <a16:creationId xmlns:a16="http://schemas.microsoft.com/office/drawing/2014/main" id="{B0C7C8F5-B44C-A37E-477A-54F72060E0CC}"/>
+              </a:ext>
+            </a:extLst>
+          </p:cNvPr>
+          <p:cNvSpPr>
+            <a:spLocks noGrp="1"/>
+          </p:cNvSpPr>
+          <p:nvPr>
+            <p:ph type="title"/>
+          </p:nvPr>
+        </p:nvSpPr>
+        <p:spPr/>
+        <p:txBody>
+          <a:bodyPr/>
+          <a:lstStyle/>
+          <a:p>
+            <a:r>
+              <a:rPr lang="en-US" dirty="0"/>
+              <a:t>Entity-Relationship Diagram (ERD) for </a:t>
+            </a:r>
+            <a:r>
+              <a:rPr lang="en-US" dirty="0" err="1"/>
+              <a:t>RxBuddy</a:t>
+            </a:r>
+            <a:endParaRPr lang="en-US" dirty="0"/>
+          </a:p>
+        </p:txBody>
+      </p:sp>
+      <p:pic>
+        <p:nvPicPr>
+          <p:cNvPr id="6" name="Content Placeholder 5" descr="A diagram of a medical application&#10;&#10;Description automatically generated">
+            <a:extLst>
+              <a:ext uri="{FF2B5EF4-FFF2-40B4-BE49-F238E27FC236}">
+                <a16:creationId xmlns:a16="http://schemas.microsoft.com/office/drawing/2014/main" id="{F8B1C873-0D85-BAE3-77C1-846F6FE3A593}"/>
+              </a:ext>
+            </a:extLst>
+          </p:cNvPr>
+          <p:cNvPicPr>
+            <a:picLocks noGrp="1" noChangeAspect="1"/>
+          </p:cNvPicPr>
+          <p:nvPr>
+            <p:ph sz="half" idx="2"/>
+          </p:nvPr>
+        </p:nvPicPr>
+        <p:blipFill>
+          <a:blip r:embed="rId2"/>
+          <a:stretch>
+            <a:fillRect/>
+          </a:stretch>
+        </p:blipFill>
+        <p:spPr>
+          <a:xfrm>
+            <a:off x="2300659" y="1717990"/>
+            <a:ext cx="7590681" cy="4410352"/>
+          </a:xfrm>
+        </p:spPr>
+      </p:pic>
+    </p:spTree>
+    <p:extLst>
+      <p:ext uri="{BB962C8B-B14F-4D97-AF65-F5344CB8AC3E}">
+        <p14:creationId xmlns:p14="http://schemas.microsoft.com/office/powerpoint/2010/main" val="199650453"/>
+      </p:ext>
+    </p:extLst>
+  </p:cSld>
+  <p:clrMapOvr>
+    <a:masterClrMapping/>
+  </p:clrMapOvr>
+</p:sld>
+</file>
+
+<file path=ppt/slides/slide6.xml><?xml version="1.0" encoding="utf-8"?>
 <p:sld xmlns:a="http://schemas.openxmlformats.org/drawingml/2006/main" xmlns:r="http://schemas.openxmlformats.org/officeDocument/2006/relationships" xmlns:p="http://schemas.openxmlformats.org/presentationml/2006/main">
   <p:cSld>
     <p:bg>
@@ -11467,26 +11560,6 @@
 </file>
 
 <file path=customXml/item2.xml><?xml version="1.0" encoding="utf-8"?>
-<p:properties xmlns:p="http://schemas.microsoft.com/office/2006/metadata/properties" xmlns:xsi="http://www.w3.org/2001/XMLSchema-instance" xmlns:pc="http://schemas.microsoft.com/office/infopath/2007/PartnerControls">
-  <documentManagement>
-    <_ip_UnifiedCompliancePolicyUIAction xmlns="http://schemas.microsoft.com/sharepoint/v3" xsi:nil="true"/>
-    <Image xmlns="71af3243-3dd4-4a8d-8c0d-dd76da1f02a5">
-      <Url xsi:nil="true"/>
-      <Description xsi:nil="true"/>
-    </Image>
-    <Status xmlns="71af3243-3dd4-4a8d-8c0d-dd76da1f02a5">Not started</Status>
-    <Background xmlns="71af3243-3dd4-4a8d-8c0d-dd76da1f02a5">false</Background>
-    <_ip_UnifiedCompliancePolicyProperties xmlns="http://schemas.microsoft.com/sharepoint/v3" xsi:nil="true"/>
-    <ImageTagsTaxHTField xmlns="71af3243-3dd4-4a8d-8c0d-dd76da1f02a5">
-      <Terms xmlns="http://schemas.microsoft.com/office/infopath/2007/PartnerControls"/>
-    </ImageTagsTaxHTField>
-    <TaxCatchAll xmlns="230e9df3-be65-4c73-a93b-d1236ebd677e" xsi:nil="true"/>
-    <MediaServiceKeyPoints xmlns="71af3243-3dd4-4a8d-8c0d-dd76da1f02a5" xsi:nil="true"/>
-  </documentManagement>
-</p:properties>
-</file>
-
-<file path=customXml/item3.xml><?xml version="1.0" encoding="utf-8"?>
 <ct:contentTypeSchema xmlns:ct="http://schemas.microsoft.com/office/2006/metadata/contentType" xmlns:ma="http://schemas.microsoft.com/office/2006/metadata/properties/metaAttributes" ct:_="" ma:_="" ma:contentTypeName="Document" ma:contentTypeID="0x01010079F111ED35F8CC479449609E8A0923A6" ma:contentTypeVersion="28" ma:contentTypeDescription="Create a new document." ma:contentTypeScope="" ma:versionID="60f5a4f2d2b0abadcf532d48ebf9cb71">
   <xsd:schema xmlns:xsd="http://www.w3.org/2001/XMLSchema" xmlns:xs="http://www.w3.org/2001/XMLSchema" xmlns:p="http://schemas.microsoft.com/office/2006/metadata/properties" xmlns:ns1="http://schemas.microsoft.com/sharepoint/v3" xmlns:ns2="71af3243-3dd4-4a8d-8c0d-dd76da1f02a5" xmlns:ns3="16c05727-aa75-4e4a-9b5f-8a80a1165891" xmlns:ns4="230e9df3-be65-4c73-a93b-d1236ebd677e" targetNamespace="http://schemas.microsoft.com/office/2006/metadata/properties" ma:root="true" ma:fieldsID="7dd78129e6a1811f84807ad11c651531" ns1:_="" ns2:_="" ns3:_="" ns4:_="">
     <xsd:import namespace="http://schemas.microsoft.com/sharepoint/v3"/>
@@ -11798,6 +11871,26 @@
 </ct:contentTypeSchema>
 </file>
 
+<file path=customXml/item3.xml><?xml version="1.0" encoding="utf-8"?>
+<p:properties xmlns:p="http://schemas.microsoft.com/office/2006/metadata/properties" xmlns:xsi="http://www.w3.org/2001/XMLSchema-instance" xmlns:pc="http://schemas.microsoft.com/office/infopath/2007/PartnerControls">
+  <documentManagement>
+    <_ip_UnifiedCompliancePolicyUIAction xmlns="http://schemas.microsoft.com/sharepoint/v3" xsi:nil="true"/>
+    <Image xmlns="71af3243-3dd4-4a8d-8c0d-dd76da1f02a5">
+      <Url xsi:nil="true"/>
+      <Description xsi:nil="true"/>
+    </Image>
+    <Status xmlns="71af3243-3dd4-4a8d-8c0d-dd76da1f02a5">Not started</Status>
+    <Background xmlns="71af3243-3dd4-4a8d-8c0d-dd76da1f02a5">false</Background>
+    <_ip_UnifiedCompliancePolicyProperties xmlns="http://schemas.microsoft.com/sharepoint/v3" xsi:nil="true"/>
+    <ImageTagsTaxHTField xmlns="71af3243-3dd4-4a8d-8c0d-dd76da1f02a5">
+      <Terms xmlns="http://schemas.microsoft.com/office/infopath/2007/PartnerControls"/>
+    </ImageTagsTaxHTField>
+    <TaxCatchAll xmlns="230e9df3-be65-4c73-a93b-d1236ebd677e" xsi:nil="true"/>
+    <MediaServiceKeyPoints xmlns="71af3243-3dd4-4a8d-8c0d-dd76da1f02a5" xsi:nil="true"/>
+  </documentManagement>
+</p:properties>
+</file>
+
 <file path=customXml/itemProps1.xml><?xml version="1.0" encoding="utf-8"?>
 <ds:datastoreItem xmlns:ds="http://schemas.openxmlformats.org/officeDocument/2006/customXml" ds:itemID="{19D1F84C-D1FD-4B1B-9CFD-8E0D96AC4DF2}">
   <ds:schemaRefs>
@@ -11807,18 +11900,6 @@
 </file>
 
 <file path=customXml/itemProps2.xml><?xml version="1.0" encoding="utf-8"?>
-<ds:datastoreItem xmlns:ds="http://schemas.openxmlformats.org/officeDocument/2006/customXml" ds:itemID="{5A00B2AC-C335-4100-B8B3-2D9F49A72906}">
-  <ds:schemaRefs>
-    <ds:schemaRef ds:uri="http://schemas.microsoft.com/office/2006/metadata/properties"/>
-    <ds:schemaRef ds:uri="http://schemas.microsoft.com/office/infopath/2007/PartnerControls"/>
-    <ds:schemaRef ds:uri="http://schemas.microsoft.com/sharepoint/v3"/>
-    <ds:schemaRef ds:uri="71af3243-3dd4-4a8d-8c0d-dd76da1f02a5"/>
-    <ds:schemaRef ds:uri="230e9df3-be65-4c73-a93b-d1236ebd677e"/>
-  </ds:schemaRefs>
-</ds:datastoreItem>
-</file>
-
-<file path=customXml/itemProps3.xml><?xml version="1.0" encoding="utf-8"?>
 <ds:datastoreItem xmlns:ds="http://schemas.openxmlformats.org/officeDocument/2006/customXml" ds:itemID="{0037C456-A6DA-4DEE-A3FB-4EC3058FD086}">
   <ds:schemaRefs>
     <ds:schemaRef ds:uri="http://schemas.microsoft.com/office/2006/metadata/contentType"/>
@@ -11839,6 +11920,18 @@
 </ds:datastoreItem>
 </file>
 
+<file path=customXml/itemProps3.xml><?xml version="1.0" encoding="utf-8"?>
+<ds:datastoreItem xmlns:ds="http://schemas.openxmlformats.org/officeDocument/2006/customXml" ds:itemID="{5A00B2AC-C335-4100-B8B3-2D9F49A72906}">
+  <ds:schemaRefs>
+    <ds:schemaRef ds:uri="http://schemas.microsoft.com/office/2006/metadata/properties"/>
+    <ds:schemaRef ds:uri="http://schemas.microsoft.com/office/infopath/2007/PartnerControls"/>
+    <ds:schemaRef ds:uri="http://schemas.microsoft.com/sharepoint/v3"/>
+    <ds:schemaRef ds:uri="71af3243-3dd4-4a8d-8c0d-dd76da1f02a5"/>
+    <ds:schemaRef ds:uri="230e9df3-be65-4c73-a93b-d1236ebd677e"/>
+  </ds:schemaRefs>
+</ds:datastoreItem>
+</file>
+
 <file path=docMetadata/LabelInfo.xml><?xml version="1.0" encoding="utf-8"?>
 <clbl:labelList xmlns:clbl="http://schemas.microsoft.com/office/2020/mipLabelMetadata"/>
 </file>
</xml_diff>